<commit_message>
Publish committee memo and final submission files
</commit_message>
<xml_diff>
--- a/Final Submission/Presentation.pptx
+++ b/Final Submission/Presentation.pptx
@@ -301,7 +301,7 @@
           <a:lstStyle/>
           <a:p>
             <a:pPr>
-              <a:defRPr sz="1200">
+              <a:defRPr sz="1500">
                 <a:latin typeface="Lato"/>
               </a:defRPr>
             </a:pPr>
@@ -319,7 +319,7 @@
         <a:lstStyle/>
         <a:p>
           <a:pPr>
-            <a:defRPr sz="1300">
+            <a:defRPr sz="1500">
               <a:latin typeface="Lato"/>
             </a:defRPr>
           </a:pPr>
@@ -456,7 +456,7 @@
           <a:lstStyle/>
           <a:p>
             <a:pPr>
-              <a:defRPr sz="1200">
+              <a:defRPr sz="1500">
                 <a:latin typeface="Lato"/>
               </a:defRPr>
             </a:pPr>
@@ -1067,7 +1067,7 @@
           <a:lstStyle/>
           <a:p>
             <a:pPr>
-              <a:defRPr sz="1200">
+              <a:defRPr sz="1500">
                 <a:latin typeface="Lato"/>
               </a:defRPr>
             </a:pPr>
@@ -1086,7 +1086,7 @@
         <a:lstStyle/>
         <a:p>
           <a:pPr>
-            <a:defRPr sz="1300">
+            <a:defRPr sz="1500">
               <a:latin typeface="Lato"/>
             </a:defRPr>
           </a:pPr>
@@ -1225,7 +1225,7 @@
           <a:lstStyle/>
           <a:p>
             <a:pPr>
-              <a:defRPr sz="1200">
+              <a:defRPr sz="1500">
                 <a:latin typeface="Lato"/>
               </a:defRPr>
             </a:pPr>
@@ -1420,7 +1420,7 @@
           <a:lstStyle/>
           <a:p>
             <a:pPr>
-              <a:defRPr sz="1200">
+              <a:defRPr sz="1500">
                 <a:latin typeface="Lato"/>
               </a:defRPr>
             </a:pPr>
@@ -1438,7 +1438,7 @@
         <a:lstStyle/>
         <a:p>
           <a:pPr>
-            <a:defRPr sz="1300">
+            <a:defRPr sz="1500">
               <a:latin typeface="Lato"/>
             </a:defRPr>
           </a:pPr>
@@ -1593,7 +1593,7 @@
           <a:lstStyle/>
           <a:p>
             <a:pPr>
-              <a:defRPr sz="1200">
+              <a:defRPr sz="1500">
                 <a:latin typeface="Lato"/>
               </a:defRPr>
             </a:pPr>
@@ -1733,7 +1733,7 @@
           <a:lstStyle/>
           <a:p>
             <a:pPr>
-              <a:defRPr sz="1200">
+              <a:defRPr sz="1500">
                 <a:latin typeface="Lato"/>
               </a:defRPr>
             </a:pPr>
@@ -1853,7 +1853,7 @@
         <a:lstStyle/>
         <a:p>
           <a:pPr>
-            <a:defRPr sz="1300">
+            <a:defRPr sz="1500">
               <a:latin typeface="Lato"/>
             </a:defRPr>
           </a:pPr>
@@ -2028,7 +2028,7 @@
           <a:lstStyle/>
           <a:p>
             <a:pPr>
-              <a:defRPr sz="1200">
+              <a:defRPr sz="1500">
                 <a:latin typeface="Lato"/>
               </a:defRPr>
             </a:pPr>
@@ -2222,7 +2222,7 @@
           <a:lstStyle/>
           <a:p>
             <a:pPr>
-              <a:defRPr sz="1200">
+              <a:defRPr sz="1500">
                 <a:latin typeface="Lato"/>
               </a:defRPr>
             </a:pPr>
@@ -2240,7 +2240,7 @@
         <a:lstStyle/>
         <a:p>
           <a:pPr>
-            <a:defRPr sz="1300">
+            <a:defRPr sz="1500">
               <a:latin typeface="Lato"/>
             </a:defRPr>
           </a:pPr>
@@ -2377,7 +2377,7 @@
           <a:lstStyle/>
           <a:p>
             <a:pPr>
-              <a:defRPr sz="1200">
+              <a:defRPr sz="1500">
                 <a:latin typeface="Lato"/>
               </a:defRPr>
             </a:pPr>
@@ -2523,7 +2523,7 @@
           <a:lstStyle/>
           <a:p>
             <a:pPr>
-              <a:defRPr sz="1200">
+              <a:defRPr sz="1500">
                 <a:latin typeface="Lato"/>
               </a:defRPr>
             </a:pPr>

</xml_diff>